<commit_message>
fix: add Demo/Walkthrough slide 9 to PPTX (matches brief requirements) feat: wire up streaming ingestion endpoint POST /api/stream/ingest (bonus)
- PPTX now has 13 slides matching exact brief order:
  1 Cover, 2 Problem, 3 Solution, 4 Architecture, 5 Ingestion/Norm,
  6 Dedup, 7 Schema/Gap, 8 Description, 9 Demo, 10 Quality,
  11 Dashboard, 12 Results, 13 Scale
- Streaming ingestion: upload a single file -> pipeline runs immediately
  for that file alone, no batching required (STREAMING_MODE bonus)
- 37/37 tests still passing
</commit_message>
<xml_diff>
--- a/docs/presentation.pptx
+++ b/docs/presentation.pptx
@@ -13,6 +13,7 @@
     <p:sldId id="261" r:id="rId12"/>
     <p:sldId id="262" r:id="rId13"/>
     <p:sldId id="263" r:id="rId14"/>
+    <p:sldId id="268" r:id="rId19"/>
     <p:sldId id="264" r:id="rId15"/>
     <p:sldId id="265" r:id="rId16"/>
     <p:sldId id="266" r:id="rId17"/>
@@ -7979,6 +7980,2134 @@
                 </a:solidFill>
               </a:rPr>
               <a:t>Each agent is independently deployable, testable, and replaceable. When a supplier changes format — only IngestionAgent updates. When the LLM improves — only Description and Gap agents benefit. No other architecture gives you that modularity at zero coupling cost.</a:t>
+            </a:r>
+          </a:p>
+        </p:txBody>
+      </p:sp>
+    </p:spTree>
+  </p:cSld>
+  <p:clrMapOvr>
+    <a:masterClrMapping/>
+  </p:clrMapOvr>
+</p:sld>
+</file>
+
+<file path=ppt/slides/slide13.xml><?xml version="1.0" encoding="utf-8"?>
+<p:sld xmlns:a="http://schemas.openxmlformats.org/drawingml/2006/main" xmlns:p="http://schemas.openxmlformats.org/presentationml/2006/main" xmlns:r="http://schemas.openxmlformats.org/officeDocument/2006/relationships">
+  <p:cSld>
+    <p:bg>
+      <p:bgPr>
+        <a:solidFill>
+          <a:srgbClr val="F8F7F4"/>
+        </a:solidFill>
+        <a:effectLst/>
+      </p:bgPr>
+    </p:bg>
+    <p:spTree>
+      <p:nvGrpSpPr>
+        <p:cNvPr id="1" name=""/>
+        <p:cNvGrpSpPr/>
+        <p:nvPr/>
+      </p:nvGrpSpPr>
+      <p:grpSpPr/>
+      <p:sp>
+        <p:nvSpPr>
+          <p:cNvPr id="2" name="Rectangle 1"/>
+          <p:cNvSpPr/>
+          <p:nvPr/>
+        </p:nvSpPr>
+        <p:spPr>
+          <a:xfrm>
+            <a:off x="0" y="0"/>
+            <a:ext cx="12188952" cy="1463040"/>
+          </a:xfrm>
+          <a:prstGeom prst="rect">
+            <a:avLst/>
+          </a:prstGeom>
+          <a:solidFill>
+            <a:srgbClr val="0D9488"/>
+          </a:solidFill>
+          <a:ln>
+            <a:noFill/>
+          </a:ln>
+        </p:spPr>
+        <p:style>
+          <a:lnRef idx="1">
+            <a:schemeClr val="accent1"/>
+          </a:lnRef>
+          <a:fillRef idx="3">
+            <a:schemeClr val="accent1"/>
+          </a:fillRef>
+          <a:effectRef idx="2">
+            <a:schemeClr val="accent1"/>
+          </a:effectRef>
+          <a:fontRef idx="minor">
+            <a:schemeClr val="lt1"/>
+          </a:fontRef>
+        </p:style>
+        <p:txBody>
+          <a:bodyPr rtlCol="0" anchor="ctr"/>
+          <a:lstStyle/>
+          <a:p>
+            <a:pPr algn="ctr"/>
+          </a:p>
+        </p:txBody>
+      </p:sp>
+      <p:sp>
+        <p:nvSpPr>
+          <p:cNvPr id="3" name="TextBox 2"/>
+          <p:cNvSpPr txBox="1"/>
+          <p:nvPr/>
+        </p:nvSpPr>
+        <p:spPr>
+          <a:xfrm>
+            <a:off x="457200" y="182880"/>
+            <a:ext cx="10972800" cy="731520"/>
+          </a:xfrm>
+          <a:prstGeom prst="rect">
+            <a:avLst/>
+          </a:prstGeom>
+          <a:noFill/>
+        </p:spPr>
+        <p:txBody>
+          <a:bodyPr wrap="square">
+            <a:spAutoFit/>
+          </a:bodyPr>
+          <a:lstStyle/>
+          <a:p>
+            <a:pPr algn="l"/>
+            <a:r>
+              <a:rPr sz="3400" b="1">
+                <a:solidFill>
+                  <a:srgbClr val="FFFFFF"/>
+                </a:solidFill>
+              </a:rPr>
+              <a:t>Demo / Walkthrough</a:t>
+            </a:r>
+          </a:p>
+        </p:txBody>
+      </p:sp>
+      <p:sp>
+        <p:nvSpPr>
+          <p:cNvPr id="4" name="TextBox 3"/>
+          <p:cNvSpPr txBox="1"/>
+          <p:nvPr/>
+        </p:nvSpPr>
+        <p:spPr>
+          <a:xfrm>
+            <a:off x="457200" y="868680"/>
+            <a:ext cx="10972800" cy="457200"/>
+          </a:xfrm>
+          <a:prstGeom prst="rect">
+            <a:avLst/>
+          </a:prstGeom>
+          <a:noFill/>
+        </p:spPr>
+        <p:txBody>
+          <a:bodyPr wrap="square">
+            <a:spAutoFit/>
+          </a:bodyPr>
+          <a:lstStyle/>
+          <a:p>
+            <a:pPr algn="l"/>
+            <a:r>
+              <a:rPr sz="1600" b="0">
+                <a:solidFill>
+                  <a:srgbClr val="A7F3D0"/>
+                </a:solidFill>
+              </a:rPr>
+              <a:t>Pipeline running on 3 supplier feeds — before vs after per SKU</a:t>
+            </a:r>
+          </a:p>
+        </p:txBody>
+      </p:sp>
+      <p:sp>
+        <p:nvSpPr>
+          <p:cNvPr id="5" name="TextBox 4"/>
+          <p:cNvSpPr txBox="1"/>
+          <p:nvPr/>
+        </p:nvSpPr>
+        <p:spPr>
+          <a:xfrm>
+            <a:off x="11795760" y="6492240"/>
+            <a:ext cx="365760" cy="274320"/>
+          </a:xfrm>
+          <a:prstGeom prst="rect">
+            <a:avLst/>
+          </a:prstGeom>
+          <a:noFill/>
+        </p:spPr>
+        <p:txBody>
+          <a:bodyPr wrap="square">
+            <a:spAutoFit/>
+          </a:bodyPr>
+          <a:lstStyle/>
+          <a:p>
+            <a:pPr algn="r"/>
+            <a:r>
+              <a:rPr sz="1000" b="0">
+                <a:solidFill>
+                  <a:srgbClr val="A8A29E"/>
+                </a:solidFill>
+              </a:rPr>
+              <a:t>9</a:t>
+            </a:r>
+          </a:p>
+        </p:txBody>
+      </p:sp>
+      <p:sp>
+        <p:nvSpPr>
+          <p:cNvPr id="6" name="Rounded Rectangle 5"/>
+          <p:cNvSpPr/>
+          <p:nvPr/>
+        </p:nvSpPr>
+        <p:spPr>
+          <a:xfrm>
+            <a:off x="457200" y="1600200"/>
+            <a:ext cx="5303520" cy="1005840"/>
+          </a:xfrm>
+          <a:prstGeom prst="roundRect">
+            <a:avLst>
+              <a:gd name="adj" fmla="val 5000"/>
+            </a:avLst>
+          </a:prstGeom>
+          <a:solidFill>
+            <a:srgbClr val="1C1917"/>
+          </a:solidFill>
+          <a:ln>
+            <a:noFill/>
+          </a:ln>
+        </p:spPr>
+        <p:style>
+          <a:lnRef idx="1">
+            <a:schemeClr val="accent1"/>
+          </a:lnRef>
+          <a:fillRef idx="3">
+            <a:schemeClr val="accent1"/>
+          </a:fillRef>
+          <a:effectRef idx="2">
+            <a:schemeClr val="accent1"/>
+          </a:effectRef>
+          <a:fontRef idx="minor">
+            <a:schemeClr val="lt1"/>
+          </a:fontRef>
+        </p:style>
+        <p:txBody>
+          <a:bodyPr rtlCol="0" anchor="ctr"/>
+          <a:lstStyle/>
+          <a:p>
+            <a:pPr algn="ctr"/>
+          </a:p>
+        </p:txBody>
+      </p:sp>
+      <p:sp>
+        <p:nvSpPr>
+          <p:cNvPr id="7" name="TextBox 6"/>
+          <p:cNvSpPr txBox="1"/>
+          <p:nvPr/>
+        </p:nvSpPr>
+        <p:spPr>
+          <a:xfrm>
+            <a:off x="640080" y="1737360"/>
+            <a:ext cx="4937760" cy="347472"/>
+          </a:xfrm>
+          <a:prstGeom prst="rect">
+            <a:avLst/>
+          </a:prstGeom>
+          <a:noFill/>
+        </p:spPr>
+        <p:txBody>
+          <a:bodyPr wrap="square">
+            <a:spAutoFit/>
+          </a:bodyPr>
+          <a:lstStyle/>
+          <a:p>
+            <a:pPr algn="l"/>
+            <a:r>
+              <a:rPr sz="1200" b="0">
+                <a:solidFill>
+                  <a:srgbClr val="86EFAC"/>
+                </a:solidFill>
+              </a:rPr>
+              <a:t>$ ollama serve          # terminal 1</a:t>
+            </a:r>
+          </a:p>
+        </p:txBody>
+      </p:sp>
+      <p:sp>
+        <p:nvSpPr>
+          <p:cNvPr id="8" name="TextBox 7"/>
+          <p:cNvSpPr txBox="1"/>
+          <p:nvPr/>
+        </p:nvSpPr>
+        <p:spPr>
+          <a:xfrm>
+            <a:off x="640080" y="2057400"/>
+            <a:ext cx="4937760" cy="347472"/>
+          </a:xfrm>
+          <a:prstGeom prst="rect">
+            <a:avLst/>
+          </a:prstGeom>
+          <a:noFill/>
+        </p:spPr>
+        <p:txBody>
+          <a:bodyPr wrap="square">
+            <a:spAutoFit/>
+          </a:bodyPr>
+          <a:lstStyle/>
+          <a:p>
+            <a:pPr algn="l"/>
+            <a:r>
+              <a:rPr sz="1200" b="0">
+                <a:solidFill>
+                  <a:srgbClr val="86EFAC"/>
+                </a:solidFill>
+              </a:rPr>
+              <a:t>$ python run_api.py     # terminal 2</a:t>
+            </a:r>
+          </a:p>
+        </p:txBody>
+      </p:sp>
+      <p:sp>
+        <p:nvSpPr>
+          <p:cNvPr id="9" name="TextBox 8"/>
+          <p:cNvSpPr txBox="1"/>
+          <p:nvPr/>
+        </p:nvSpPr>
+        <p:spPr>
+          <a:xfrm>
+            <a:off x="6035040" y="1600200"/>
+            <a:ext cx="5943600" cy="365760"/>
+          </a:xfrm>
+          <a:prstGeom prst="rect">
+            <a:avLst/>
+          </a:prstGeom>
+          <a:noFill/>
+        </p:spPr>
+        <p:txBody>
+          <a:bodyPr wrap="square">
+            <a:spAutoFit/>
+          </a:bodyPr>
+          <a:lstStyle/>
+          <a:p>
+            <a:pPr algn="l"/>
+            <a:r>
+              <a:rPr sz="1400" b="1">
+                <a:solidFill>
+                  <a:srgbClr val="1C1917"/>
+                </a:solidFill>
+              </a:rPr>
+              <a:t>8-Step Pipeline</a:t>
+            </a:r>
+          </a:p>
+        </p:txBody>
+      </p:sp>
+      <p:sp>
+        <p:nvSpPr>
+          <p:cNvPr id="10" name="Rounded Rectangle 9"/>
+          <p:cNvSpPr/>
+          <p:nvPr/>
+        </p:nvSpPr>
+        <p:spPr>
+          <a:xfrm>
+            <a:off x="6035040" y="2057400"/>
+            <a:ext cx="1417320" cy="1234440"/>
+          </a:xfrm>
+          <a:prstGeom prst="roundRect">
+            <a:avLst>
+              <a:gd name="adj" fmla="val 5000"/>
+            </a:avLst>
+          </a:prstGeom>
+          <a:solidFill>
+            <a:srgbClr val="4F46E5"/>
+          </a:solidFill>
+          <a:ln>
+            <a:noFill/>
+          </a:ln>
+        </p:spPr>
+        <p:style>
+          <a:lnRef idx="1">
+            <a:schemeClr val="accent1"/>
+          </a:lnRef>
+          <a:fillRef idx="3">
+            <a:schemeClr val="accent1"/>
+          </a:fillRef>
+          <a:effectRef idx="2">
+            <a:schemeClr val="accent1"/>
+          </a:effectRef>
+          <a:fontRef idx="minor">
+            <a:schemeClr val="lt1"/>
+          </a:fontRef>
+        </p:style>
+        <p:txBody>
+          <a:bodyPr rtlCol="0" anchor="ctr"/>
+          <a:lstStyle/>
+          <a:p>
+            <a:pPr algn="ctr"/>
+          </a:p>
+        </p:txBody>
+      </p:sp>
+      <p:sp>
+        <p:nvSpPr>
+          <p:cNvPr id="11" name="TextBox 10"/>
+          <p:cNvSpPr txBox="1"/>
+          <p:nvPr/>
+        </p:nvSpPr>
+        <p:spPr>
+          <a:xfrm>
+            <a:off x="6108192" y="2103120"/>
+            <a:ext cx="365760" cy="365760"/>
+          </a:xfrm>
+          <a:prstGeom prst="rect">
+            <a:avLst/>
+          </a:prstGeom>
+          <a:noFill/>
+        </p:spPr>
+        <p:txBody>
+          <a:bodyPr wrap="square">
+            <a:spAutoFit/>
+          </a:bodyPr>
+          <a:lstStyle/>
+          <a:p>
+            <a:pPr algn="ctr"/>
+            <a:r>
+              <a:rPr sz="1400" b="1">
+                <a:solidFill>
+                  <a:srgbClr val="FFFFFF"/>
+                </a:solidFill>
+              </a:rPr>
+              <a:t>1</a:t>
+            </a:r>
+          </a:p>
+        </p:txBody>
+      </p:sp>
+      <p:sp>
+        <p:nvSpPr>
+          <p:cNvPr id="12" name="TextBox 11"/>
+          <p:cNvSpPr txBox="1"/>
+          <p:nvPr/>
+        </p:nvSpPr>
+        <p:spPr>
+          <a:xfrm>
+            <a:off x="6108192" y="2468880"/>
+            <a:ext cx="1261872" cy="347472"/>
+          </a:xfrm>
+          <a:prstGeom prst="rect">
+            <a:avLst/>
+          </a:prstGeom>
+          <a:noFill/>
+        </p:spPr>
+        <p:txBody>
+          <a:bodyPr wrap="square">
+            <a:spAutoFit/>
+          </a:bodyPr>
+          <a:lstStyle/>
+          <a:p>
+            <a:pPr algn="l"/>
+            <a:r>
+              <a:rPr sz="1100" b="1">
+                <a:solidFill>
+                  <a:srgbClr val="FFFFFF"/>
+                </a:solidFill>
+              </a:rPr>
+              <a:t>Ingest</a:t>
+            </a:r>
+          </a:p>
+        </p:txBody>
+      </p:sp>
+      <p:sp>
+        <p:nvSpPr>
+          <p:cNvPr id="13" name="TextBox 12"/>
+          <p:cNvSpPr txBox="1"/>
+          <p:nvPr/>
+        </p:nvSpPr>
+        <p:spPr>
+          <a:xfrm>
+            <a:off x="6108192" y="2807208"/>
+            <a:ext cx="1261872" cy="384048"/>
+          </a:xfrm>
+          <a:prstGeom prst="rect">
+            <a:avLst/>
+          </a:prstGeom>
+          <a:noFill/>
+        </p:spPr>
+        <p:txBody>
+          <a:bodyPr wrap="square">
+            <a:spAutoFit/>
+          </a:bodyPr>
+          <a:lstStyle/>
+          <a:p>
+            <a:pPr algn="l"/>
+            <a:r>
+              <a:rPr sz="900" b="0">
+                <a:solidFill>
+                  <a:srgbClr val="E0E7FF"/>
+                </a:solidFill>
+              </a:rPr>
+              <a:t>18 RawProducts</a:t>
+            </a:r>
+          </a:p>
+        </p:txBody>
+      </p:sp>
+      <p:sp>
+        <p:nvSpPr>
+          <p:cNvPr id="14" name="Rounded Rectangle 13"/>
+          <p:cNvSpPr/>
+          <p:nvPr/>
+        </p:nvSpPr>
+        <p:spPr>
+          <a:xfrm>
+            <a:off x="7571231" y="2057400"/>
+            <a:ext cx="1417320" cy="1234440"/>
+          </a:xfrm>
+          <a:prstGeom prst="roundRect">
+            <a:avLst>
+              <a:gd name="adj" fmla="val 5000"/>
+            </a:avLst>
+          </a:prstGeom>
+          <a:solidFill>
+            <a:srgbClr val="0D9488"/>
+          </a:solidFill>
+          <a:ln>
+            <a:noFill/>
+          </a:ln>
+        </p:spPr>
+        <p:style>
+          <a:lnRef idx="1">
+            <a:schemeClr val="accent1"/>
+          </a:lnRef>
+          <a:fillRef idx="3">
+            <a:schemeClr val="accent1"/>
+          </a:fillRef>
+          <a:effectRef idx="2">
+            <a:schemeClr val="accent1"/>
+          </a:effectRef>
+          <a:fontRef idx="minor">
+            <a:schemeClr val="lt1"/>
+          </a:fontRef>
+        </p:style>
+        <p:txBody>
+          <a:bodyPr rtlCol="0" anchor="ctr"/>
+          <a:lstStyle/>
+          <a:p>
+            <a:pPr algn="ctr"/>
+          </a:p>
+        </p:txBody>
+      </p:sp>
+      <p:sp>
+        <p:nvSpPr>
+          <p:cNvPr id="15" name="TextBox 14"/>
+          <p:cNvSpPr txBox="1"/>
+          <p:nvPr/>
+        </p:nvSpPr>
+        <p:spPr>
+          <a:xfrm>
+            <a:off x="7644383" y="2103120"/>
+            <a:ext cx="365760" cy="365760"/>
+          </a:xfrm>
+          <a:prstGeom prst="rect">
+            <a:avLst/>
+          </a:prstGeom>
+          <a:noFill/>
+        </p:spPr>
+        <p:txBody>
+          <a:bodyPr wrap="square">
+            <a:spAutoFit/>
+          </a:bodyPr>
+          <a:lstStyle/>
+          <a:p>
+            <a:pPr algn="ctr"/>
+            <a:r>
+              <a:rPr sz="1400" b="1">
+                <a:solidFill>
+                  <a:srgbClr val="FFFFFF"/>
+                </a:solidFill>
+              </a:rPr>
+              <a:t>2</a:t>
+            </a:r>
+          </a:p>
+        </p:txBody>
+      </p:sp>
+      <p:sp>
+        <p:nvSpPr>
+          <p:cNvPr id="16" name="TextBox 15"/>
+          <p:cNvSpPr txBox="1"/>
+          <p:nvPr/>
+        </p:nvSpPr>
+        <p:spPr>
+          <a:xfrm>
+            <a:off x="7644383" y="2468880"/>
+            <a:ext cx="1261872" cy="347472"/>
+          </a:xfrm>
+          <a:prstGeom prst="rect">
+            <a:avLst/>
+          </a:prstGeom>
+          <a:noFill/>
+        </p:spPr>
+        <p:txBody>
+          <a:bodyPr wrap="square">
+            <a:spAutoFit/>
+          </a:bodyPr>
+          <a:lstStyle/>
+          <a:p>
+            <a:pPr algn="l"/>
+            <a:r>
+              <a:rPr sz="1100" b="1">
+                <a:solidFill>
+                  <a:srgbClr val="FFFFFF"/>
+                </a:solidFill>
+              </a:rPr>
+              <a:t>Normalize</a:t>
+            </a:r>
+          </a:p>
+        </p:txBody>
+      </p:sp>
+      <p:sp>
+        <p:nvSpPr>
+          <p:cNvPr id="17" name="TextBox 16"/>
+          <p:cNvSpPr txBox="1"/>
+          <p:nvPr/>
+        </p:nvSpPr>
+        <p:spPr>
+          <a:xfrm>
+            <a:off x="7644383" y="2807208"/>
+            <a:ext cx="1261872" cy="384048"/>
+          </a:xfrm>
+          <a:prstGeom prst="rect">
+            <a:avLst/>
+          </a:prstGeom>
+          <a:noFill/>
+        </p:spPr>
+        <p:txBody>
+          <a:bodyPr wrap="square">
+            <a:spAutoFit/>
+          </a:bodyPr>
+          <a:lstStyle/>
+          <a:p>
+            <a:pPr algn="l"/>
+            <a:r>
+              <a:rPr sz="900" b="0">
+                <a:solidFill>
+                  <a:srgbClr val="E0E7FF"/>
+                </a:solidFill>
+              </a:rPr>
+              <a:t>Fields+Lang</a:t>
+            </a:r>
+          </a:p>
+        </p:txBody>
+      </p:sp>
+      <p:sp>
+        <p:nvSpPr>
+          <p:cNvPr id="18" name="Rounded Rectangle 17"/>
+          <p:cNvSpPr/>
+          <p:nvPr/>
+        </p:nvSpPr>
+        <p:spPr>
+          <a:xfrm>
+            <a:off x="9107424" y="2057400"/>
+            <a:ext cx="1417320" cy="1234440"/>
+          </a:xfrm>
+          <a:prstGeom prst="roundRect">
+            <a:avLst>
+              <a:gd name="adj" fmla="val 5000"/>
+            </a:avLst>
+          </a:prstGeom>
+          <a:solidFill>
+            <a:srgbClr val="7C3AED"/>
+          </a:solidFill>
+          <a:ln>
+            <a:noFill/>
+          </a:ln>
+        </p:spPr>
+        <p:style>
+          <a:lnRef idx="1">
+            <a:schemeClr val="accent1"/>
+          </a:lnRef>
+          <a:fillRef idx="3">
+            <a:schemeClr val="accent1"/>
+          </a:fillRef>
+          <a:effectRef idx="2">
+            <a:schemeClr val="accent1"/>
+          </a:effectRef>
+          <a:fontRef idx="minor">
+            <a:schemeClr val="lt1"/>
+          </a:fontRef>
+        </p:style>
+        <p:txBody>
+          <a:bodyPr rtlCol="0" anchor="ctr"/>
+          <a:lstStyle/>
+          <a:p>
+            <a:pPr algn="ctr"/>
+          </a:p>
+        </p:txBody>
+      </p:sp>
+      <p:sp>
+        <p:nvSpPr>
+          <p:cNvPr id="19" name="TextBox 18"/>
+          <p:cNvSpPr txBox="1"/>
+          <p:nvPr/>
+        </p:nvSpPr>
+        <p:spPr>
+          <a:xfrm>
+            <a:off x="9180576" y="2103120"/>
+            <a:ext cx="365760" cy="365760"/>
+          </a:xfrm>
+          <a:prstGeom prst="rect">
+            <a:avLst/>
+          </a:prstGeom>
+          <a:noFill/>
+        </p:spPr>
+        <p:txBody>
+          <a:bodyPr wrap="square">
+            <a:spAutoFit/>
+          </a:bodyPr>
+          <a:lstStyle/>
+          <a:p>
+            <a:pPr algn="ctr"/>
+            <a:r>
+              <a:rPr sz="1400" b="1">
+                <a:solidFill>
+                  <a:srgbClr val="FFFFFF"/>
+                </a:solidFill>
+              </a:rPr>
+              <a:t>3</a:t>
+            </a:r>
+          </a:p>
+        </p:txBody>
+      </p:sp>
+      <p:sp>
+        <p:nvSpPr>
+          <p:cNvPr id="20" name="TextBox 19"/>
+          <p:cNvSpPr txBox="1"/>
+          <p:nvPr/>
+        </p:nvSpPr>
+        <p:spPr>
+          <a:xfrm>
+            <a:off x="9180576" y="2468880"/>
+            <a:ext cx="1261872" cy="347472"/>
+          </a:xfrm>
+          <a:prstGeom prst="rect">
+            <a:avLst/>
+          </a:prstGeom>
+          <a:noFill/>
+        </p:spPr>
+        <p:txBody>
+          <a:bodyPr wrap="square">
+            <a:spAutoFit/>
+          </a:bodyPr>
+          <a:lstStyle/>
+          <a:p>
+            <a:pPr algn="l"/>
+            <a:r>
+              <a:rPr sz="1100" b="1">
+                <a:solidFill>
+                  <a:srgbClr val="FFFFFF"/>
+                </a:solidFill>
+              </a:rPr>
+              <a:t>Deduplicate</a:t>
+            </a:r>
+          </a:p>
+        </p:txBody>
+      </p:sp>
+      <p:sp>
+        <p:nvSpPr>
+          <p:cNvPr id="21" name="TextBox 20"/>
+          <p:cNvSpPr txBox="1"/>
+          <p:nvPr/>
+        </p:nvSpPr>
+        <p:spPr>
+          <a:xfrm>
+            <a:off x="9180576" y="2807208"/>
+            <a:ext cx="1261872" cy="384048"/>
+          </a:xfrm>
+          <a:prstGeom prst="rect">
+            <a:avLst/>
+          </a:prstGeom>
+          <a:noFill/>
+        </p:spPr>
+        <p:txBody>
+          <a:bodyPr wrap="square">
+            <a:spAutoFit/>
+          </a:bodyPr>
+          <a:lstStyle/>
+          <a:p>
+            <a:pPr algn="l"/>
+            <a:r>
+              <a:rPr sz="900" b="0">
+                <a:solidFill>
+                  <a:srgbClr val="E0E7FF"/>
+                </a:solidFill>
+              </a:rPr>
+              <a:t>TF-IDF</a:t>
+            </a:r>
+          </a:p>
+        </p:txBody>
+      </p:sp>
+      <p:sp>
+        <p:nvSpPr>
+          <p:cNvPr id="22" name="Rounded Rectangle 21"/>
+          <p:cNvSpPr/>
+          <p:nvPr/>
+        </p:nvSpPr>
+        <p:spPr>
+          <a:xfrm>
+            <a:off x="10643616" y="2057400"/>
+            <a:ext cx="1417320" cy="1234440"/>
+          </a:xfrm>
+          <a:prstGeom prst="roundRect">
+            <a:avLst>
+              <a:gd name="adj" fmla="val 5000"/>
+            </a:avLst>
+          </a:prstGeom>
+          <a:solidFill>
+            <a:srgbClr val="D97706"/>
+          </a:solidFill>
+          <a:ln>
+            <a:noFill/>
+          </a:ln>
+        </p:spPr>
+        <p:style>
+          <a:lnRef idx="1">
+            <a:schemeClr val="accent1"/>
+          </a:lnRef>
+          <a:fillRef idx="3">
+            <a:schemeClr val="accent1"/>
+          </a:fillRef>
+          <a:effectRef idx="2">
+            <a:schemeClr val="accent1"/>
+          </a:effectRef>
+          <a:fontRef idx="minor">
+            <a:schemeClr val="lt1"/>
+          </a:fontRef>
+        </p:style>
+        <p:txBody>
+          <a:bodyPr rtlCol="0" anchor="ctr"/>
+          <a:lstStyle/>
+          <a:p>
+            <a:pPr algn="ctr"/>
+          </a:p>
+        </p:txBody>
+      </p:sp>
+      <p:sp>
+        <p:nvSpPr>
+          <p:cNvPr id="23" name="TextBox 22"/>
+          <p:cNvSpPr txBox="1"/>
+          <p:nvPr/>
+        </p:nvSpPr>
+        <p:spPr>
+          <a:xfrm>
+            <a:off x="10716768" y="2103120"/>
+            <a:ext cx="365760" cy="365760"/>
+          </a:xfrm>
+          <a:prstGeom prst="rect">
+            <a:avLst/>
+          </a:prstGeom>
+          <a:noFill/>
+        </p:spPr>
+        <p:txBody>
+          <a:bodyPr wrap="square">
+            <a:spAutoFit/>
+          </a:bodyPr>
+          <a:lstStyle/>
+          <a:p>
+            <a:pPr algn="ctr"/>
+            <a:r>
+              <a:rPr sz="1400" b="1">
+                <a:solidFill>
+                  <a:srgbClr val="FFFFFF"/>
+                </a:solidFill>
+              </a:rPr>
+              <a:t>4</a:t>
+            </a:r>
+          </a:p>
+        </p:txBody>
+      </p:sp>
+      <p:sp>
+        <p:nvSpPr>
+          <p:cNvPr id="24" name="TextBox 23"/>
+          <p:cNvSpPr txBox="1"/>
+          <p:nvPr/>
+        </p:nvSpPr>
+        <p:spPr>
+          <a:xfrm>
+            <a:off x="10716768" y="2468880"/>
+            <a:ext cx="1261872" cy="347472"/>
+          </a:xfrm>
+          <a:prstGeom prst="rect">
+            <a:avLst/>
+          </a:prstGeom>
+          <a:noFill/>
+        </p:spPr>
+        <p:txBody>
+          <a:bodyPr wrap="square">
+            <a:spAutoFit/>
+          </a:bodyPr>
+          <a:lstStyle/>
+          <a:p>
+            <a:pPr algn="l"/>
+            <a:r>
+              <a:rPr sz="1100" b="1">
+                <a:solidFill>
+                  <a:srgbClr val="FFFFFF"/>
+                </a:solidFill>
+              </a:rPr>
+              <a:t>Map</a:t>
+            </a:r>
+          </a:p>
+        </p:txBody>
+      </p:sp>
+      <p:sp>
+        <p:nvSpPr>
+          <p:cNvPr id="25" name="TextBox 24"/>
+          <p:cNvSpPr txBox="1"/>
+          <p:nvPr/>
+        </p:nvSpPr>
+        <p:spPr>
+          <a:xfrm>
+            <a:off x="10716768" y="2807208"/>
+            <a:ext cx="1261872" cy="384048"/>
+          </a:xfrm>
+          <a:prstGeom prst="rect">
+            <a:avLst/>
+          </a:prstGeom>
+          <a:noFill/>
+        </p:spPr>
+        <p:txBody>
+          <a:bodyPr wrap="square">
+            <a:spAutoFit/>
+          </a:bodyPr>
+          <a:lstStyle/>
+          <a:p>
+            <a:pPr algn="l"/>
+            <a:r>
+              <a:rPr sz="900" b="0">
+                <a:solidFill>
+                  <a:srgbClr val="E0E7FF"/>
+                </a:solidFill>
+              </a:rPr>
+              <a:t>Schema</a:t>
+            </a:r>
+          </a:p>
+        </p:txBody>
+      </p:sp>
+      <p:sp>
+        <p:nvSpPr>
+          <p:cNvPr id="26" name="Rounded Rectangle 25"/>
+          <p:cNvSpPr/>
+          <p:nvPr/>
+        </p:nvSpPr>
+        <p:spPr>
+          <a:xfrm>
+            <a:off x="6035040" y="3520440"/>
+            <a:ext cx="1417320" cy="1234440"/>
+          </a:xfrm>
+          <a:prstGeom prst="roundRect">
+            <a:avLst>
+              <a:gd name="adj" fmla="val 5000"/>
+            </a:avLst>
+          </a:prstGeom>
+          <a:solidFill>
+            <a:srgbClr val="0D9488"/>
+          </a:solidFill>
+          <a:ln>
+            <a:noFill/>
+          </a:ln>
+        </p:spPr>
+        <p:style>
+          <a:lnRef idx="1">
+            <a:schemeClr val="accent1"/>
+          </a:lnRef>
+          <a:fillRef idx="3">
+            <a:schemeClr val="accent1"/>
+          </a:fillRef>
+          <a:effectRef idx="2">
+            <a:schemeClr val="accent1"/>
+          </a:effectRef>
+          <a:fontRef idx="minor">
+            <a:schemeClr val="lt1"/>
+          </a:fontRef>
+        </p:style>
+        <p:txBody>
+          <a:bodyPr rtlCol="0" anchor="ctr"/>
+          <a:lstStyle/>
+          <a:p>
+            <a:pPr algn="ctr"/>
+          </a:p>
+        </p:txBody>
+      </p:sp>
+      <p:sp>
+        <p:nvSpPr>
+          <p:cNvPr id="27" name="TextBox 26"/>
+          <p:cNvSpPr txBox="1"/>
+          <p:nvPr/>
+        </p:nvSpPr>
+        <p:spPr>
+          <a:xfrm>
+            <a:off x="6108192" y="3566160"/>
+            <a:ext cx="365760" cy="365760"/>
+          </a:xfrm>
+          <a:prstGeom prst="rect">
+            <a:avLst/>
+          </a:prstGeom>
+          <a:noFill/>
+        </p:spPr>
+        <p:txBody>
+          <a:bodyPr wrap="square">
+            <a:spAutoFit/>
+          </a:bodyPr>
+          <a:lstStyle/>
+          <a:p>
+            <a:pPr algn="ctr"/>
+            <a:r>
+              <a:rPr sz="1400" b="1">
+                <a:solidFill>
+                  <a:srgbClr val="FFFFFF"/>
+                </a:solidFill>
+              </a:rPr>
+              <a:t>5</a:t>
+            </a:r>
+          </a:p>
+        </p:txBody>
+      </p:sp>
+      <p:sp>
+        <p:nvSpPr>
+          <p:cNvPr id="28" name="TextBox 27"/>
+          <p:cNvSpPr txBox="1"/>
+          <p:nvPr/>
+        </p:nvSpPr>
+        <p:spPr>
+          <a:xfrm>
+            <a:off x="6108192" y="3931920"/>
+            <a:ext cx="1261872" cy="347472"/>
+          </a:xfrm>
+          <a:prstGeom prst="rect">
+            <a:avLst/>
+          </a:prstGeom>
+          <a:noFill/>
+        </p:spPr>
+        <p:txBody>
+          <a:bodyPr wrap="square">
+            <a:spAutoFit/>
+          </a:bodyPr>
+          <a:lstStyle/>
+          <a:p>
+            <a:pPr algn="l"/>
+            <a:r>
+              <a:rPr sz="1100" b="1">
+                <a:solidFill>
+                  <a:srgbClr val="FFFFFF"/>
+                </a:solidFill>
+              </a:rPr>
+              <a:t>Fill Gaps</a:t>
+            </a:r>
+          </a:p>
+        </p:txBody>
+      </p:sp>
+      <p:sp>
+        <p:nvSpPr>
+          <p:cNvPr id="29" name="TextBox 28"/>
+          <p:cNvSpPr txBox="1"/>
+          <p:nvPr/>
+        </p:nvSpPr>
+        <p:spPr>
+          <a:xfrm>
+            <a:off x="6108192" y="4270248"/>
+            <a:ext cx="1261872" cy="384048"/>
+          </a:xfrm>
+          <a:prstGeom prst="rect">
+            <a:avLst/>
+          </a:prstGeom>
+          <a:noFill/>
+        </p:spPr>
+        <p:txBody>
+          <a:bodyPr wrap="square">
+            <a:spAutoFit/>
+          </a:bodyPr>
+          <a:lstStyle/>
+          <a:p>
+            <a:pPr algn="l"/>
+            <a:r>
+              <a:rPr sz="900" b="0">
+                <a:solidFill>
+                  <a:srgbClr val="E0E7FF"/>
+                </a:solidFill>
+              </a:rPr>
+              <a:t>15 fields</a:t>
+            </a:r>
+          </a:p>
+        </p:txBody>
+      </p:sp>
+      <p:sp>
+        <p:nvSpPr>
+          <p:cNvPr id="30" name="Rounded Rectangle 29"/>
+          <p:cNvSpPr/>
+          <p:nvPr/>
+        </p:nvSpPr>
+        <p:spPr>
+          <a:xfrm>
+            <a:off x="7571231" y="3520440"/>
+            <a:ext cx="1417320" cy="1234440"/>
+          </a:xfrm>
+          <a:prstGeom prst="roundRect">
+            <a:avLst>
+              <a:gd name="adj" fmla="val 5000"/>
+            </a:avLst>
+          </a:prstGeom>
+          <a:solidFill>
+            <a:srgbClr val="16A34A"/>
+          </a:solidFill>
+          <a:ln>
+            <a:noFill/>
+          </a:ln>
+        </p:spPr>
+        <p:style>
+          <a:lnRef idx="1">
+            <a:schemeClr val="accent1"/>
+          </a:lnRef>
+          <a:fillRef idx="3">
+            <a:schemeClr val="accent1"/>
+          </a:fillRef>
+          <a:effectRef idx="2">
+            <a:schemeClr val="accent1"/>
+          </a:effectRef>
+          <a:fontRef idx="minor">
+            <a:schemeClr val="lt1"/>
+          </a:fontRef>
+        </p:style>
+        <p:txBody>
+          <a:bodyPr rtlCol="0" anchor="ctr"/>
+          <a:lstStyle/>
+          <a:p>
+            <a:pPr algn="ctr"/>
+          </a:p>
+        </p:txBody>
+      </p:sp>
+      <p:sp>
+        <p:nvSpPr>
+          <p:cNvPr id="31" name="TextBox 30"/>
+          <p:cNvSpPr txBox="1"/>
+          <p:nvPr/>
+        </p:nvSpPr>
+        <p:spPr>
+          <a:xfrm>
+            <a:off x="7644383" y="3566160"/>
+            <a:ext cx="365760" cy="365760"/>
+          </a:xfrm>
+          <a:prstGeom prst="rect">
+            <a:avLst/>
+          </a:prstGeom>
+          <a:noFill/>
+        </p:spPr>
+        <p:txBody>
+          <a:bodyPr wrap="square">
+            <a:spAutoFit/>
+          </a:bodyPr>
+          <a:lstStyle/>
+          <a:p>
+            <a:pPr algn="ctr"/>
+            <a:r>
+              <a:rPr sz="1400" b="1">
+                <a:solidFill>
+                  <a:srgbClr val="FFFFFF"/>
+                </a:solidFill>
+              </a:rPr>
+              <a:t>6</a:t>
+            </a:r>
+          </a:p>
+        </p:txBody>
+      </p:sp>
+      <p:sp>
+        <p:nvSpPr>
+          <p:cNvPr id="32" name="TextBox 31"/>
+          <p:cNvSpPr txBox="1"/>
+          <p:nvPr/>
+        </p:nvSpPr>
+        <p:spPr>
+          <a:xfrm>
+            <a:off x="7644383" y="3931920"/>
+            <a:ext cx="1261872" cy="347472"/>
+          </a:xfrm>
+          <a:prstGeom prst="rect">
+            <a:avLst/>
+          </a:prstGeom>
+          <a:noFill/>
+        </p:spPr>
+        <p:txBody>
+          <a:bodyPr wrap="square">
+            <a:spAutoFit/>
+          </a:bodyPr>
+          <a:lstStyle/>
+          <a:p>
+            <a:pPr algn="l"/>
+            <a:r>
+              <a:rPr sz="1100" b="1">
+                <a:solidFill>
+                  <a:srgbClr val="FFFFFF"/>
+                </a:solidFill>
+              </a:rPr>
+              <a:t>Describe</a:t>
+            </a:r>
+          </a:p>
+        </p:txBody>
+      </p:sp>
+      <p:sp>
+        <p:nvSpPr>
+          <p:cNvPr id="33" name="TextBox 32"/>
+          <p:cNvSpPr txBox="1"/>
+          <p:nvPr/>
+        </p:nvSpPr>
+        <p:spPr>
+          <a:xfrm>
+            <a:off x="7644383" y="4270248"/>
+            <a:ext cx="1261872" cy="384048"/>
+          </a:xfrm>
+          <a:prstGeom prst="rect">
+            <a:avLst/>
+          </a:prstGeom>
+          <a:noFill/>
+        </p:spPr>
+        <p:txBody>
+          <a:bodyPr wrap="square">
+            <a:spAutoFit/>
+          </a:bodyPr>
+          <a:lstStyle/>
+          <a:p>
+            <a:pPr algn="l"/>
+            <a:r>
+              <a:rPr sz="900" b="0">
+                <a:solidFill>
+                  <a:srgbClr val="E0E7FF"/>
+                </a:solidFill>
+              </a:rPr>
+              <a:t>18 SEO</a:t>
+            </a:r>
+          </a:p>
+        </p:txBody>
+      </p:sp>
+      <p:sp>
+        <p:nvSpPr>
+          <p:cNvPr id="34" name="Rounded Rectangle 33"/>
+          <p:cNvSpPr/>
+          <p:nvPr/>
+        </p:nvSpPr>
+        <p:spPr>
+          <a:xfrm>
+            <a:off x="9107424" y="3520440"/>
+            <a:ext cx="1417320" cy="1234440"/>
+          </a:xfrm>
+          <a:prstGeom prst="roundRect">
+            <a:avLst>
+              <a:gd name="adj" fmla="val 5000"/>
+            </a:avLst>
+          </a:prstGeom>
+          <a:solidFill>
+            <a:srgbClr val="4F46E5"/>
+          </a:solidFill>
+          <a:ln>
+            <a:noFill/>
+          </a:ln>
+        </p:spPr>
+        <p:style>
+          <a:lnRef idx="1">
+            <a:schemeClr val="accent1"/>
+          </a:lnRef>
+          <a:fillRef idx="3">
+            <a:schemeClr val="accent1"/>
+          </a:fillRef>
+          <a:effectRef idx="2">
+            <a:schemeClr val="accent1"/>
+          </a:effectRef>
+          <a:fontRef idx="minor">
+            <a:schemeClr val="lt1"/>
+          </a:fontRef>
+        </p:style>
+        <p:txBody>
+          <a:bodyPr rtlCol="0" anchor="ctr"/>
+          <a:lstStyle/>
+          <a:p>
+            <a:pPr algn="ctr"/>
+          </a:p>
+        </p:txBody>
+      </p:sp>
+      <p:sp>
+        <p:nvSpPr>
+          <p:cNvPr id="35" name="TextBox 34"/>
+          <p:cNvSpPr txBox="1"/>
+          <p:nvPr/>
+        </p:nvSpPr>
+        <p:spPr>
+          <a:xfrm>
+            <a:off x="9180576" y="3566160"/>
+            <a:ext cx="365760" cy="365760"/>
+          </a:xfrm>
+          <a:prstGeom prst="rect">
+            <a:avLst/>
+          </a:prstGeom>
+          <a:noFill/>
+        </p:spPr>
+        <p:txBody>
+          <a:bodyPr wrap="square">
+            <a:spAutoFit/>
+          </a:bodyPr>
+          <a:lstStyle/>
+          <a:p>
+            <a:pPr algn="ctr"/>
+            <a:r>
+              <a:rPr sz="1400" b="1">
+                <a:solidFill>
+                  <a:srgbClr val="FFFFFF"/>
+                </a:solidFill>
+              </a:rPr>
+              <a:t>7</a:t>
+            </a:r>
+          </a:p>
+        </p:txBody>
+      </p:sp>
+      <p:sp>
+        <p:nvSpPr>
+          <p:cNvPr id="36" name="TextBox 35"/>
+          <p:cNvSpPr txBox="1"/>
+          <p:nvPr/>
+        </p:nvSpPr>
+        <p:spPr>
+          <a:xfrm>
+            <a:off x="9180576" y="3931920"/>
+            <a:ext cx="1261872" cy="347472"/>
+          </a:xfrm>
+          <a:prstGeom prst="rect">
+            <a:avLst/>
+          </a:prstGeom>
+          <a:noFill/>
+        </p:spPr>
+        <p:txBody>
+          <a:bodyPr wrap="square">
+            <a:spAutoFit/>
+          </a:bodyPr>
+          <a:lstStyle/>
+          <a:p>
+            <a:pPr algn="l"/>
+            <a:r>
+              <a:rPr sz="1100" b="1">
+                <a:solidFill>
+                  <a:srgbClr val="FFFFFF"/>
+                </a:solidFill>
+              </a:rPr>
+              <a:t>Score</a:t>
+            </a:r>
+          </a:p>
+        </p:txBody>
+      </p:sp>
+      <p:sp>
+        <p:nvSpPr>
+          <p:cNvPr id="37" name="TextBox 36"/>
+          <p:cNvSpPr txBox="1"/>
+          <p:nvPr/>
+        </p:nvSpPr>
+        <p:spPr>
+          <a:xfrm>
+            <a:off x="9180576" y="4270248"/>
+            <a:ext cx="1261872" cy="384048"/>
+          </a:xfrm>
+          <a:prstGeom prst="rect">
+            <a:avLst/>
+          </a:prstGeom>
+          <a:noFill/>
+        </p:spPr>
+        <p:txBody>
+          <a:bodyPr wrap="square">
+            <a:spAutoFit/>
+          </a:bodyPr>
+          <a:lstStyle/>
+          <a:p>
+            <a:pPr algn="l"/>
+            <a:r>
+              <a:rPr sz="900" b="0">
+                <a:solidFill>
+                  <a:srgbClr val="E0E7FF"/>
+                </a:solidFill>
+              </a:rPr>
+              <a:t>avg 87.9</a:t>
+            </a:r>
+          </a:p>
+        </p:txBody>
+      </p:sp>
+      <p:sp>
+        <p:nvSpPr>
+          <p:cNvPr id="38" name="Rounded Rectangle 37"/>
+          <p:cNvSpPr/>
+          <p:nvPr/>
+        </p:nvSpPr>
+        <p:spPr>
+          <a:xfrm>
+            <a:off x="10643616" y="3520440"/>
+            <a:ext cx="1417320" cy="1234440"/>
+          </a:xfrm>
+          <a:prstGeom prst="roundRect">
+            <a:avLst>
+              <a:gd name="adj" fmla="val 5000"/>
+            </a:avLst>
+          </a:prstGeom>
+          <a:solidFill>
+            <a:srgbClr val="0D9488"/>
+          </a:solidFill>
+          <a:ln>
+            <a:noFill/>
+          </a:ln>
+        </p:spPr>
+        <p:style>
+          <a:lnRef idx="1">
+            <a:schemeClr val="accent1"/>
+          </a:lnRef>
+          <a:fillRef idx="3">
+            <a:schemeClr val="accent1"/>
+          </a:fillRef>
+          <a:effectRef idx="2">
+            <a:schemeClr val="accent1"/>
+          </a:effectRef>
+          <a:fontRef idx="minor">
+            <a:schemeClr val="lt1"/>
+          </a:fontRef>
+        </p:style>
+        <p:txBody>
+          <a:bodyPr rtlCol="0" anchor="ctr"/>
+          <a:lstStyle/>
+          <a:p>
+            <a:pPr algn="ctr"/>
+          </a:p>
+        </p:txBody>
+      </p:sp>
+      <p:sp>
+        <p:nvSpPr>
+          <p:cNvPr id="39" name="TextBox 38"/>
+          <p:cNvSpPr txBox="1"/>
+          <p:nvPr/>
+        </p:nvSpPr>
+        <p:spPr>
+          <a:xfrm>
+            <a:off x="10716768" y="3566160"/>
+            <a:ext cx="365760" cy="365760"/>
+          </a:xfrm>
+          <a:prstGeom prst="rect">
+            <a:avLst/>
+          </a:prstGeom>
+          <a:noFill/>
+        </p:spPr>
+        <p:txBody>
+          <a:bodyPr wrap="square">
+            <a:spAutoFit/>
+          </a:bodyPr>
+          <a:lstStyle/>
+          <a:p>
+            <a:pPr algn="ctr"/>
+            <a:r>
+              <a:rPr sz="1400" b="1">
+                <a:solidFill>
+                  <a:srgbClr val="FFFFFF"/>
+                </a:solidFill>
+              </a:rPr>
+              <a:t>8</a:t>
+            </a:r>
+          </a:p>
+        </p:txBody>
+      </p:sp>
+      <p:sp>
+        <p:nvSpPr>
+          <p:cNvPr id="40" name="TextBox 39"/>
+          <p:cNvSpPr txBox="1"/>
+          <p:nvPr/>
+        </p:nvSpPr>
+        <p:spPr>
+          <a:xfrm>
+            <a:off x="10716768" y="3931920"/>
+            <a:ext cx="1261872" cy="347472"/>
+          </a:xfrm>
+          <a:prstGeom prst="rect">
+            <a:avLst/>
+          </a:prstGeom>
+          <a:noFill/>
+        </p:spPr>
+        <p:txBody>
+          <a:bodyPr wrap="square">
+            <a:spAutoFit/>
+          </a:bodyPr>
+          <a:lstStyle/>
+          <a:p>
+            <a:pPr algn="l"/>
+            <a:r>
+              <a:rPr sz="1100" b="1">
+                <a:solidFill>
+                  <a:srgbClr val="FFFFFF"/>
+                </a:solidFill>
+              </a:rPr>
+              <a:t>Report</a:t>
+            </a:r>
+          </a:p>
+        </p:txBody>
+      </p:sp>
+      <p:sp>
+        <p:nvSpPr>
+          <p:cNvPr id="41" name="TextBox 40"/>
+          <p:cNvSpPr txBox="1"/>
+          <p:nvPr/>
+        </p:nvSpPr>
+        <p:spPr>
+          <a:xfrm>
+            <a:off x="10716768" y="4270248"/>
+            <a:ext cx="1261872" cy="384048"/>
+          </a:xfrm>
+          <a:prstGeom prst="rect">
+            <a:avLst/>
+          </a:prstGeom>
+          <a:noFill/>
+        </p:spPr>
+        <p:txBody>
+          <a:bodyPr wrap="square">
+            <a:spAutoFit/>
+          </a:bodyPr>
+          <a:lstStyle/>
+          <a:p>
+            <a:pPr algn="l"/>
+            <a:r>
+              <a:rPr sz="900" b="0">
+                <a:solidFill>
+                  <a:srgbClr val="E0E7FF"/>
+                </a:solidFill>
+              </a:rPr>
+              <a:t>JSON+CSV</a:t>
+            </a:r>
+          </a:p>
+        </p:txBody>
+      </p:sp>
+      <p:sp>
+        <p:nvSpPr>
+          <p:cNvPr id="42" name="TextBox 41"/>
+          <p:cNvSpPr txBox="1"/>
+          <p:nvPr/>
+        </p:nvSpPr>
+        <p:spPr>
+          <a:xfrm>
+            <a:off x="457200" y="2743200"/>
+            <a:ext cx="11430000" cy="365760"/>
+          </a:xfrm>
+          <a:prstGeom prst="rect">
+            <a:avLst/>
+          </a:prstGeom>
+          <a:noFill/>
+        </p:spPr>
+        <p:txBody>
+          <a:bodyPr wrap="square">
+            <a:spAutoFit/>
+          </a:bodyPr>
+          <a:lstStyle/>
+          <a:p>
+            <a:pPr algn="l"/>
+            <a:r>
+              <a:rPr sz="1300" b="1">
+                <a:solidFill>
+                  <a:srgbClr val="1C1917"/>
+                </a:solidFill>
+              </a:rPr>
+              <a:t>Before → After  (A002: USB-C Fast Charger 65W)</a:t>
+            </a:r>
+          </a:p>
+        </p:txBody>
+      </p:sp>
+      <p:sp>
+        <p:nvSpPr>
+          <p:cNvPr id="43" name="Rounded Rectangle 42"/>
+          <p:cNvSpPr/>
+          <p:nvPr/>
+        </p:nvSpPr>
+        <p:spPr>
+          <a:xfrm>
+            <a:off x="457200" y="3182112"/>
+            <a:ext cx="5303520" cy="2926080"/>
+          </a:xfrm>
+          <a:prstGeom prst="roundRect">
+            <a:avLst>
+              <a:gd name="adj" fmla="val 5000"/>
+            </a:avLst>
+          </a:prstGeom>
+          <a:solidFill>
+            <a:srgbClr val="1C1917"/>
+          </a:solidFill>
+          <a:ln>
+            <a:noFill/>
+          </a:ln>
+        </p:spPr>
+        <p:style>
+          <a:lnRef idx="1">
+            <a:schemeClr val="accent1"/>
+          </a:lnRef>
+          <a:fillRef idx="3">
+            <a:schemeClr val="accent1"/>
+          </a:fillRef>
+          <a:effectRef idx="2">
+            <a:schemeClr val="accent1"/>
+          </a:effectRef>
+          <a:fontRef idx="minor">
+            <a:schemeClr val="lt1"/>
+          </a:fontRef>
+        </p:style>
+        <p:txBody>
+          <a:bodyPr rtlCol="0" anchor="ctr"/>
+          <a:lstStyle/>
+          <a:p>
+            <a:pPr algn="ctr"/>
+          </a:p>
+        </p:txBody>
+      </p:sp>
+      <p:sp>
+        <p:nvSpPr>
+          <p:cNvPr id="44" name="TextBox 43"/>
+          <p:cNvSpPr txBox="1"/>
+          <p:nvPr/>
+        </p:nvSpPr>
+        <p:spPr>
+          <a:xfrm>
+            <a:off x="594360" y="3255264"/>
+            <a:ext cx="2743200" cy="274320"/>
+          </a:xfrm>
+          <a:prstGeom prst="rect">
+            <a:avLst/>
+          </a:prstGeom>
+          <a:noFill/>
+        </p:spPr>
+        <p:txBody>
+          <a:bodyPr wrap="square">
+            <a:spAutoFit/>
+          </a:bodyPr>
+          <a:lstStyle/>
+          <a:p>
+            <a:pPr algn="l"/>
+            <a:r>
+              <a:rPr sz="1000" b="1">
+                <a:solidFill>
+                  <a:srgbClr val="E11D48"/>
+                </a:solidFill>
+              </a:rPr>
+              <a:t>SUPPLIER INPUT</a:t>
+            </a:r>
+          </a:p>
+        </p:txBody>
+      </p:sp>
+      <p:sp>
+        <p:nvSpPr>
+          <p:cNvPr id="45" name="TextBox 44"/>
+          <p:cNvSpPr txBox="1"/>
+          <p:nvPr/>
+        </p:nvSpPr>
+        <p:spPr>
+          <a:xfrm>
+            <a:off x="594360" y="3566160"/>
+            <a:ext cx="5029200" cy="320040"/>
+          </a:xfrm>
+          <a:prstGeom prst="rect">
+            <a:avLst/>
+          </a:prstGeom>
+          <a:noFill/>
+        </p:spPr>
+        <p:txBody>
+          <a:bodyPr wrap="square">
+            <a:spAutoFit/>
+          </a:bodyPr>
+          <a:lstStyle/>
+          <a:p>
+            <a:pPr algn="l"/>
+            <a:r>
+              <a:rPr sz="1000" b="0">
+                <a:solidFill>
+                  <a:srgbClr val="D6D3D1"/>
+                </a:solidFill>
+              </a:rPr>
+              <a:t>"sku": "A002"</a:t>
+            </a:r>
+          </a:p>
+        </p:txBody>
+      </p:sp>
+      <p:sp>
+        <p:nvSpPr>
+          <p:cNvPr id="46" name="TextBox 45"/>
+          <p:cNvSpPr txBox="1"/>
+          <p:nvPr/>
+        </p:nvSpPr>
+        <p:spPr>
+          <a:xfrm>
+            <a:off x="594360" y="3904487"/>
+            <a:ext cx="5029200" cy="320040"/>
+          </a:xfrm>
+          <a:prstGeom prst="rect">
+            <a:avLst/>
+          </a:prstGeom>
+          <a:noFill/>
+        </p:spPr>
+        <p:txBody>
+          <a:bodyPr wrap="square">
+            <a:spAutoFit/>
+          </a:bodyPr>
+          <a:lstStyle/>
+          <a:p>
+            <a:pPr algn="l"/>
+            <a:r>
+              <a:rPr sz="1000" b="0">
+                <a:solidFill>
+                  <a:srgbClr val="D6D3D1"/>
+                </a:solidFill>
+              </a:rPr>
+              <a:t>"name": "USB-C Fast Charger 65W"</a:t>
+            </a:r>
+          </a:p>
+        </p:txBody>
+      </p:sp>
+      <p:sp>
+        <p:nvSpPr>
+          <p:cNvPr id="47" name="TextBox 46"/>
+          <p:cNvSpPr txBox="1"/>
+          <p:nvPr/>
+        </p:nvSpPr>
+        <p:spPr>
+          <a:xfrm>
+            <a:off x="594360" y="4242816"/>
+            <a:ext cx="5029200" cy="320040"/>
+          </a:xfrm>
+          <a:prstGeom prst="rect">
+            <a:avLst/>
+          </a:prstGeom>
+          <a:noFill/>
+        </p:spPr>
+        <p:txBody>
+          <a:bodyPr wrap="square">
+            <a:spAutoFit/>
+          </a:bodyPr>
+          <a:lstStyle/>
+          <a:p>
+            <a:pPr algn="l"/>
+            <a:r>
+              <a:rPr sz="1000" b="0">
+                <a:solidFill>
+                  <a:srgbClr val="E11D48"/>
+                </a:solidFill>
+              </a:rPr>
+              <a:t>"price": null  ← missing</a:t>
+            </a:r>
+          </a:p>
+        </p:txBody>
+      </p:sp>
+      <p:sp>
+        <p:nvSpPr>
+          <p:cNvPr id="48" name="TextBox 47"/>
+          <p:cNvSpPr txBox="1"/>
+          <p:nvPr/>
+        </p:nvSpPr>
+        <p:spPr>
+          <a:xfrm>
+            <a:off x="594360" y="4581144"/>
+            <a:ext cx="5029200" cy="320040"/>
+          </a:xfrm>
+          <a:prstGeom prst="rect">
+            <a:avLst/>
+          </a:prstGeom>
+          <a:noFill/>
+        </p:spPr>
+        <p:txBody>
+          <a:bodyPr wrap="square">
+            <a:spAutoFit/>
+          </a:bodyPr>
+          <a:lstStyle/>
+          <a:p>
+            <a:pPr algn="l"/>
+            <a:r>
+              <a:rPr sz="1000" b="0">
+                <a:solidFill>
+                  <a:srgbClr val="D6D3D1"/>
+                </a:solidFill>
+              </a:rPr>
+              <a:t>"color": "white"</a:t>
+            </a:r>
+          </a:p>
+        </p:txBody>
+      </p:sp>
+      <p:sp>
+        <p:nvSpPr>
+          <p:cNvPr id="49" name="TextBox 48"/>
+          <p:cNvSpPr txBox="1"/>
+          <p:nvPr/>
+        </p:nvSpPr>
+        <p:spPr>
+          <a:xfrm>
+            <a:off x="594360" y="4919472"/>
+            <a:ext cx="5029200" cy="320040"/>
+          </a:xfrm>
+          <a:prstGeom prst="rect">
+            <a:avLst/>
+          </a:prstGeom>
+          <a:noFill/>
+        </p:spPr>
+        <p:txBody>
+          <a:bodyPr wrap="square">
+            <a:spAutoFit/>
+          </a:bodyPr>
+          <a:lstStyle/>
+          <a:p>
+            <a:pPr algn="l"/>
+            <a:r>
+              <a:rPr sz="1000" b="0">
+                <a:solidFill>
+                  <a:srgbClr val="E11D48"/>
+                </a:solidFill>
+              </a:rPr>
+              <a:t>"category": null  ← missing</a:t>
+            </a:r>
+          </a:p>
+        </p:txBody>
+      </p:sp>
+      <p:sp>
+        <p:nvSpPr>
+          <p:cNvPr id="50" name="TextBox 49"/>
+          <p:cNvSpPr txBox="1"/>
+          <p:nvPr/>
+        </p:nvSpPr>
+        <p:spPr>
+          <a:xfrm>
+            <a:off x="594360" y="5257800"/>
+            <a:ext cx="5029200" cy="320040"/>
+          </a:xfrm>
+          <a:prstGeom prst="rect">
+            <a:avLst/>
+          </a:prstGeom>
+          <a:noFill/>
+        </p:spPr>
+        <p:txBody>
+          <a:bodyPr wrap="square">
+            <a:spAutoFit/>
+          </a:bodyPr>
+          <a:lstStyle/>
+          <a:p>
+            <a:pPr algn="l"/>
+            <a:r>
+              <a:rPr sz="1000" b="0">
+                <a:solidFill>
+                  <a:srgbClr val="D6D3D1"/>
+                </a:solidFill>
+              </a:rPr>
+              <a:t>"description": "charges fast"</a:t>
+            </a:r>
+          </a:p>
+        </p:txBody>
+      </p:sp>
+      <p:sp>
+        <p:nvSpPr>
+          <p:cNvPr id="51" name="TextBox 50"/>
+          <p:cNvSpPr txBox="1"/>
+          <p:nvPr/>
+        </p:nvSpPr>
+        <p:spPr>
+          <a:xfrm>
+            <a:off x="5577840" y="4389120"/>
+            <a:ext cx="365760" cy="457200"/>
+          </a:xfrm>
+          <a:prstGeom prst="rect">
+            <a:avLst/>
+          </a:prstGeom>
+          <a:noFill/>
+        </p:spPr>
+        <p:txBody>
+          <a:bodyPr wrap="square">
+            <a:spAutoFit/>
+          </a:bodyPr>
+          <a:lstStyle/>
+          <a:p>
+            <a:pPr algn="ctr"/>
+            <a:r>
+              <a:rPr sz="2400" b="1">
+                <a:solidFill>
+                  <a:srgbClr val="0D9488"/>
+                </a:solidFill>
+              </a:rPr>
+              <a:t>→</a:t>
+            </a:r>
+          </a:p>
+        </p:txBody>
+      </p:sp>
+      <p:sp>
+        <p:nvSpPr>
+          <p:cNvPr id="52" name="Rounded Rectangle 51"/>
+          <p:cNvSpPr/>
+          <p:nvPr/>
+        </p:nvSpPr>
+        <p:spPr>
+          <a:xfrm>
+            <a:off x="5989320" y="3182112"/>
+            <a:ext cx="6035040" cy="2926080"/>
+          </a:xfrm>
+          <a:prstGeom prst="roundRect">
+            <a:avLst>
+              <a:gd name="adj" fmla="val 5000"/>
+            </a:avLst>
+          </a:prstGeom>
+          <a:solidFill>
+            <a:srgbClr val="0A2B1A"/>
+          </a:solidFill>
+          <a:ln>
+            <a:noFill/>
+          </a:ln>
+        </p:spPr>
+        <p:style>
+          <a:lnRef idx="1">
+            <a:schemeClr val="accent1"/>
+          </a:lnRef>
+          <a:fillRef idx="3">
+            <a:schemeClr val="accent1"/>
+          </a:fillRef>
+          <a:effectRef idx="2">
+            <a:schemeClr val="accent1"/>
+          </a:effectRef>
+          <a:fontRef idx="minor">
+            <a:schemeClr val="lt1"/>
+          </a:fontRef>
+        </p:style>
+        <p:txBody>
+          <a:bodyPr rtlCol="0" anchor="ctr"/>
+          <a:lstStyle/>
+          <a:p>
+            <a:pPr algn="ctr"/>
+          </a:p>
+        </p:txBody>
+      </p:sp>
+      <p:sp>
+        <p:nvSpPr>
+          <p:cNvPr id="53" name="TextBox 52"/>
+          <p:cNvSpPr txBox="1"/>
+          <p:nvPr/>
+        </p:nvSpPr>
+        <p:spPr>
+          <a:xfrm>
+            <a:off x="6126480" y="3255264"/>
+            <a:ext cx="3657600" cy="274320"/>
+          </a:xfrm>
+          <a:prstGeom prst="rect">
+            <a:avLst/>
+          </a:prstGeom>
+          <a:noFill/>
+        </p:spPr>
+        <p:txBody>
+          <a:bodyPr wrap="square">
+            <a:spAutoFit/>
+          </a:bodyPr>
+          <a:lstStyle/>
+          <a:p>
+            <a:pPr algn="l"/>
+            <a:r>
+              <a:rPr sz="1000" b="1">
+                <a:solidFill>
+                  <a:srgbClr val="16A34A"/>
+                </a:solidFill>
+              </a:rPr>
+              <a:t>ENRICHED OUTPUT</a:t>
+            </a:r>
+          </a:p>
+        </p:txBody>
+      </p:sp>
+      <p:sp>
+        <p:nvSpPr>
+          <p:cNvPr id="54" name="TextBox 53"/>
+          <p:cNvSpPr txBox="1"/>
+          <p:nvPr/>
+        </p:nvSpPr>
+        <p:spPr>
+          <a:xfrm>
+            <a:off x="6126480" y="3566160"/>
+            <a:ext cx="5760720" cy="320040"/>
+          </a:xfrm>
+          <a:prstGeom prst="rect">
+            <a:avLst/>
+          </a:prstGeom>
+          <a:noFill/>
+        </p:spPr>
+        <p:txBody>
+          <a:bodyPr wrap="square">
+            <a:spAutoFit/>
+          </a:bodyPr>
+          <a:lstStyle/>
+          <a:p>
+            <a:pPr algn="l"/>
+            <a:r>
+              <a:rPr sz="1000" b="0">
+                <a:solidFill>
+                  <a:srgbClr val="D6D3D1"/>
+                </a:solidFill>
+              </a:rPr>
+              <a:t>"sku": "SUPPLIER_A-A002"</a:t>
+            </a:r>
+          </a:p>
+        </p:txBody>
+      </p:sp>
+      <p:sp>
+        <p:nvSpPr>
+          <p:cNvPr id="55" name="TextBox 54"/>
+          <p:cNvSpPr txBox="1"/>
+          <p:nvPr/>
+        </p:nvSpPr>
+        <p:spPr>
+          <a:xfrm>
+            <a:off x="6126480" y="3904487"/>
+            <a:ext cx="5760720" cy="320040"/>
+          </a:xfrm>
+          <a:prstGeom prst="rect">
+            <a:avLst/>
+          </a:prstGeom>
+          <a:noFill/>
+        </p:spPr>
+        <p:txBody>
+          <a:bodyPr wrap="square">
+            <a:spAutoFit/>
+          </a:bodyPr>
+          <a:lstStyle/>
+          <a:p>
+            <a:pPr algn="l"/>
+            <a:r>
+              <a:rPr sz="1000" b="0">
+                <a:solidFill>
+                  <a:srgbClr val="D6D3D1"/>
+                </a:solidFill>
+              </a:rPr>
+              <a:t>"product_name": "USB-C Fast Charger 65W"</a:t>
+            </a:r>
+          </a:p>
+        </p:txBody>
+      </p:sp>
+      <p:sp>
+        <p:nvSpPr>
+          <p:cNvPr id="56" name="TextBox 55"/>
+          <p:cNvSpPr txBox="1"/>
+          <p:nvPr/>
+        </p:nvSpPr>
+        <p:spPr>
+          <a:xfrm>
+            <a:off x="6126480" y="4242816"/>
+            <a:ext cx="5760720" cy="320040"/>
+          </a:xfrm>
+          <a:prstGeom prst="rect">
+            <a:avLst/>
+          </a:prstGeom>
+          <a:noFill/>
+        </p:spPr>
+        <p:txBody>
+          <a:bodyPr wrap="square">
+            <a:spAutoFit/>
+          </a:bodyPr>
+          <a:lstStyle/>
+          <a:p>
+            <a:pPr algn="l"/>
+            <a:r>
+              <a:rPr sz="1000" b="0">
+                <a:solidFill>
+                  <a:srgbClr val="16A34A"/>
+                </a:solidFill>
+              </a:rPr>
+              <a:t>"price_usd": 25.00  ← AUTO_FILLED by Ollama</a:t>
+            </a:r>
+          </a:p>
+        </p:txBody>
+      </p:sp>
+      <p:sp>
+        <p:nvSpPr>
+          <p:cNvPr id="57" name="TextBox 56"/>
+          <p:cNvSpPr txBox="1"/>
+          <p:nvPr/>
+        </p:nvSpPr>
+        <p:spPr>
+          <a:xfrm>
+            <a:off x="6126480" y="4581144"/>
+            <a:ext cx="5760720" cy="320040"/>
+          </a:xfrm>
+          <a:prstGeom prst="rect">
+            <a:avLst/>
+          </a:prstGeom>
+          <a:noFill/>
+        </p:spPr>
+        <p:txBody>
+          <a:bodyPr wrap="square">
+            <a:spAutoFit/>
+          </a:bodyPr>
+          <a:lstStyle/>
+          <a:p>
+            <a:pPr algn="l"/>
+            <a:r>
+              <a:rPr sz="1000" b="0">
+                <a:solidFill>
+                  <a:srgbClr val="16A34A"/>
+                </a:solidFill>
+              </a:rPr>
+              <a:t>"category": "Electronics"  ← heuristic</a:t>
+            </a:r>
+          </a:p>
+        </p:txBody>
+      </p:sp>
+      <p:sp>
+        <p:nvSpPr>
+          <p:cNvPr id="58" name="TextBox 57"/>
+          <p:cNvSpPr txBox="1"/>
+          <p:nvPr/>
+        </p:nvSpPr>
+        <p:spPr>
+          <a:xfrm>
+            <a:off x="6126480" y="4919472"/>
+            <a:ext cx="5760720" cy="320040"/>
+          </a:xfrm>
+          <a:prstGeom prst="rect">
+            <a:avLst/>
+          </a:prstGeom>
+          <a:noFill/>
+        </p:spPr>
+        <p:txBody>
+          <a:bodyPr wrap="square">
+            <a:spAutoFit/>
+          </a:bodyPr>
+          <a:lstStyle/>
+          <a:p>
+            <a:pPr algn="l"/>
+            <a:r>
+              <a:rPr sz="1000" b="0">
+                <a:solidFill>
+                  <a:srgbClr val="16A34A"/>
+                </a:solidFill>
+              </a:rPr>
+              <a:t>"description": "Power up devices... (74 words)"</a:t>
+            </a:r>
+          </a:p>
+        </p:txBody>
+      </p:sp>
+      <p:sp>
+        <p:nvSpPr>
+          <p:cNvPr id="59" name="TextBox 58"/>
+          <p:cNvSpPr txBox="1"/>
+          <p:nvPr/>
+        </p:nvSpPr>
+        <p:spPr>
+          <a:xfrm>
+            <a:off x="6126480" y="5257800"/>
+            <a:ext cx="5760720" cy="320040"/>
+          </a:xfrm>
+          <a:prstGeom prst="rect">
+            <a:avLst/>
+          </a:prstGeom>
+          <a:noFill/>
+        </p:spPr>
+        <p:txBody>
+          <a:bodyPr wrap="square">
+            <a:spAutoFit/>
+          </a:bodyPr>
+          <a:lstStyle/>
+          <a:p>
+            <a:pPr algn="l"/>
+            <a:r>
+              <a:rPr sz="1000" b="0">
+                <a:solidFill>
+                  <a:srgbClr val="D6D3D1"/>
+                </a:solidFill>
+              </a:rPr>
+              <a:t>"quality_score": 88  |  "seo_tags": [5 tags]</a:t>
             </a:r>
           </a:p>
         </p:txBody>

</xml_diff>